<commit_message>
build: generar PowerPoint estadistica descriptiva
</commit_message>
<xml_diff>
--- a/presentacion/Estadistica_Descriptiva_Biobio_FINAL.pptx
+++ b/presentacion/Estadistica_Descriptiva_Biobio_FINAL.pptx
@@ -3358,7 +3358,7 @@
         <p:spPr>
           <a:xfrm>
             <a:off x="822960" y="4709160"/>
-            <a:ext cx="7132320" cy="502920"/>
+            <a:ext cx="8595360" cy="502920"/>
           </a:xfrm>
           <a:prstGeom prst="roundRect">
             <a:avLst/>
@@ -3403,7 +3403,7 @@
         <p:spPr>
           <a:xfrm>
             <a:off x="914400" y="4818888"/>
-            <a:ext cx="6949440" cy="274320"/>
+            <a:ext cx="8412480" cy="274320"/>
           </a:xfrm>
           <a:prstGeom prst="rect">
             <a:avLst/>
@@ -3424,7 +3424,7 @@
                 </a:solidFill>
                 <a:latin typeface="Aptos"/>
               </a:rPr>
-              <a:t>Regla: no usar técnicas que no aparezcan en los laboratorios.</a:t>
+              <a:t>Metodología: Pandas, frecuencias, gráficos, tendencia central, percentiles y dispersión.</a:t>
             </a:r>
           </a:p>
         </p:txBody>

</xml_diff>